<commit_message>
Presentazione: seconda slide con lo stesso sfondo blu della prima
Co-Authored-By: Claude Fable 5.1 <noreply@anthropic.com>
Claude-Session: https://claude.ai/code/session_01Gg2EYwLr1DXy95Cqm3f4Zk
</commit_message>
<xml_diff>
--- a/presentazione/Tesoreria-Campo-Gedeoni.pptx
+++ b/presentazione/Tesoreria-Campo-Gedeoni.pptx
@@ -108,7 +108,7 @@
   <p:extLst>
     <p:ext uri="{521415D9-36F7-43E2-AB2F-B90AF26B5E84}">
       <p14:sectionLst xmlns:p14="http://schemas.microsoft.com/office/powerpoint/2010/main">
-        <p14:section name="Presentazione" id="{28e99f6c-1d8e-fb9f-2f45-af398b6f630b}">
+        <p14:section name="Presentazione" id="{1f2c35e0-4ea8-45ef-84f0-02be9de395e7}">
           <p14:sldIdLst>
             <p14:sldId id="256"/>
             <p14:sldId id="257"/>
@@ -716,7 +716,7 @@
     <p:bg>
       <p:bgPr>
         <a:solidFill>
-          <a:srgbClr val="FFFFFF"/>
+          <a:srgbClr val="163A69"/>
         </a:solidFill>
       </p:bgPr>
     </p:bg>
@@ -760,7 +760,7 @@
               <a:buNone/>
               <a:defRPr lang="en-US" sz="3000" b="1" dirty="0">
                 <a:solidFill>
-                  <a:schemeClr val="tx2"/>
+                  <a:schemeClr val="bg1"/>
                 </a:solidFill>
               </a:defRPr>
             </a:lvl1pPr>
@@ -772,7 +772,7 @@
             <a:r>
               <a:rPr lang="en-US" sz="3000" b="1" dirty="0">
                 <a:solidFill>
-                  <a:schemeClr val="tx2"/>
+                  <a:schemeClr val="bg1"/>
                 </a:solidFill>
               </a:rPr>
               <a:t>Titolo</a:t>
@@ -832,7 +832,7 @@
             <a:r>
               <a:rPr lang="en-US" sz="900" dirty="0">
                 <a:solidFill>
-                  <a:schemeClr val="accent5"/>
+                  <a:srgbClr val="8FA3BF"/>
                 </a:solidFill>
               </a:rPr>
               <a:t>Tesoreria Campo Gedeoni · campodivittoria.github.io/GideonsTesoreria.app</a:t>
@@ -1775,7 +1775,7 @@
             <a:r>
               <a:rPr lang="en-US" sz="3000" b="1" dirty="0">
                 <a:solidFill>
-                  <a:schemeClr val="tx2"/>
+                  <a:schemeClr val="bg1"/>
                 </a:solidFill>
               </a:rPr>
               <a:t>Cosa fa e perché serve al Campo</a:t>
@@ -1799,11 +1799,11 @@
             <a:avLst/>
           </a:prstGeom>
           <a:solidFill>
-            <a:srgbClr val="1F4E8C"/>
+            <a:srgbClr val="D9A420"/>
           </a:solidFill>
           <a:ln w="12700">
             <a:solidFill>
-              <a:srgbClr val="1F4E8C"/>
+              <a:srgbClr val="D9A420"/>
             </a:solidFill>
             <a:prstDash val="solid"/>
           </a:ln>
@@ -1860,7 +1860,7 @@
             <a:r>
               <a:rPr lang="en-US" sz="1500" b="1" dirty="0">
                 <a:solidFill>
-                  <a:schemeClr val="tx2"/>
+                  <a:schemeClr val="bg1"/>
                 </a:solidFill>
               </a:rPr>
               <a:t>Nuova registrazione</a:t>
@@ -1896,7 +1896,7 @@
             <a:r>
               <a:rPr lang="en-US" sz="1100" dirty="0">
                 <a:solidFill>
-                  <a:schemeClr val="tx1"/>
+                  <a:srgbClr val="CADCFC"/>
                 </a:solidFill>
               </a:rPr>
               <a:t>Data, luogo e tutti i conti in un solo foglio: offerte, PWT, Fondo Barnaba, quote annue, Gideons Card, spese</a:t>
@@ -1920,11 +1920,11 @@
             <a:avLst/>
           </a:prstGeom>
           <a:solidFill>
-            <a:srgbClr val="1F4E8C"/>
+            <a:srgbClr val="D9A420"/>
           </a:solidFill>
           <a:ln w="12700">
             <a:solidFill>
-              <a:srgbClr val="1F4E8C"/>
+              <a:srgbClr val="D9A420"/>
             </a:solidFill>
             <a:prstDash val="solid"/>
           </a:ln>
@@ -1981,7 +1981,7 @@
             <a:r>
               <a:rPr lang="en-US" sz="1500" b="1" dirty="0">
                 <a:solidFill>
-                  <a:schemeClr val="tx2"/>
+                  <a:schemeClr val="bg1"/>
                 </a:solidFill>
               </a:rPr>
               <a:t>Riepilogo e Rendiconto</a:t>
@@ -2017,7 +2017,7 @@
             <a:r>
               <a:rPr lang="en-US" sz="1100" dirty="0">
                 <a:solidFill>
-                  <a:schemeClr val="tx1"/>
+                  <a:srgbClr val="CADCFC"/>
                 </a:solidFill>
               </a:rPr>
               <a:t>Grafico della cassa, saldo di ogni conto, Pro Campo separato dagli altri; stampabile</a:t>
@@ -2041,11 +2041,11 @@
             <a:avLst/>
           </a:prstGeom>
           <a:solidFill>
-            <a:srgbClr val="1F4E8C"/>
+            <a:srgbClr val="D9A420"/>
           </a:solidFill>
           <a:ln w="12700">
             <a:solidFill>
-              <a:srgbClr val="1F4E8C"/>
+              <a:srgbClr val="D9A420"/>
             </a:solidFill>
             <a:prstDash val="solid"/>
           </a:ln>
@@ -2102,7 +2102,7 @@
             <a:r>
               <a:rPr lang="en-US" sz="1500" b="1" dirty="0">
                 <a:solidFill>
-                  <a:schemeClr val="tx2"/>
+                  <a:schemeClr val="bg1"/>
                 </a:solidFill>
               </a:rPr>
               <a:t>Storico e Bilancio</a:t>
@@ -2138,7 +2138,7 @@
             <a:r>
               <a:rPr lang="en-US" sz="1100" dirty="0">
                 <a:solidFill>
-                  <a:schemeClr val="tx1"/>
+                  <a:srgbClr val="CADCFC"/>
                 </a:solidFill>
               </a:rPr>
               <a:t>Tutte le registrazioni nel tempo e un bilancio archiviato per ogni anno fiscale</a:t>
@@ -2162,11 +2162,11 @@
             <a:avLst/>
           </a:prstGeom>
           <a:solidFill>
-            <a:srgbClr val="1F4E8C"/>
+            <a:srgbClr val="D9A420"/>
           </a:solidFill>
           <a:ln w="12700">
             <a:solidFill>
-              <a:srgbClr val="1F4E8C"/>
+              <a:srgbClr val="D9A420"/>
             </a:solidFill>
             <a:prstDash val="solid"/>
           </a:ln>
@@ -2223,7 +2223,7 @@
             <a:r>
               <a:rPr lang="en-US" sz="1500" b="1" dirty="0">
                 <a:solidFill>
-                  <a:schemeClr val="tx2"/>
+                  <a:schemeClr val="bg1"/>
                 </a:solidFill>
               </a:rPr>
               <a:t>Chiusura Cassa</a:t>
@@ -2259,7 +2259,7 @@
             <a:r>
               <a:rPr lang="en-US" sz="1100" dirty="0">
                 <a:solidFill>
-                  <a:schemeClr val="tx1"/>
+                  <a:srgbClr val="CADCFC"/>
                 </a:solidFill>
               </a:rPr>
               <a:t>Bonifico di fine anno con data, esecutore e banca; i saldi residui diventano il riporto</a:t>
@@ -2285,11 +2285,11 @@
             </a:avLst>
           </a:prstGeom>
           <a:solidFill>
-            <a:srgbClr val="EEF3FA"/>
+            <a:srgbClr val="1F4E8C"/>
           </a:solidFill>
           <a:ln w="12700">
             <a:solidFill>
-              <a:srgbClr val="EEF3FA"/>
+              <a:srgbClr val="1F4E8C"/>
             </a:solidFill>
             <a:prstDash val="solid"/>
           </a:ln>
@@ -2322,7 +2322,7 @@
             <a:r>
               <a:rPr lang="en-US" sz="1700" b="1" dirty="0">
                 <a:solidFill>
-                  <a:schemeClr val="tx2"/>
+                  <a:schemeClr val="bg1"/>
                 </a:solidFill>
               </a:rPr>
               <a:t>Perché serve</a:t>
@@ -2407,7 +2407,7 @@
             <a:r>
               <a:rPr lang="en-US" sz="1300" b="1" dirty="0">
                 <a:solidFill>
-                  <a:schemeClr val="tx2"/>
+                  <a:schemeClr val="bg1"/>
                 </a:solidFill>
               </a:rPr>
               <a:t>Contabilità interna chiara</a:t>
@@ -2443,7 +2443,7 @@
             <a:r>
               <a:rPr lang="en-US" sz="1050" dirty="0">
                 <a:solidFill>
-                  <a:schemeClr val="tx1"/>
+                  <a:srgbClr val="CADCFC"/>
                 </a:solidFill>
               </a:rPr>
               <a:t>Ogni euro raccolto nelle riunioni e nelle chiese ha una data, un luogo e un conto. Niente più fogli sparsi.</a:t>
@@ -2528,7 +2528,7 @@
             <a:r>
               <a:rPr lang="en-US" sz="1300" b="1" dirty="0">
                 <a:solidFill>
-                  <a:schemeClr val="tx2"/>
+                  <a:schemeClr val="bg1"/>
                 </a:solidFill>
               </a:rPr>
               <a:t>Passaggio tra tesorieri</a:t>
@@ -2564,7 +2564,7 @@
             <a:r>
               <a:rPr lang="en-US" sz="1050" dirty="0">
                 <a:solidFill>
-                  <a:schemeClr val="tx1"/>
+                  <a:srgbClr val="CADCFC"/>
                 </a:solidFill>
               </a:rPr>
               <a:t>Ogni tre anni il tesoriere cambia: con l’app il nuovo tesoriere trova gli stessi conti, la stessa procedura e lo storico completo. Nulla va perso nella transizione.</a:t>

</xml_diff>

<commit_message>
Presentazione: entrambe le slide su sfondo bianco
Co-Authored-By: Claude Fable 5.1 <noreply@anthropic.com>
Claude-Session: https://claude.ai/code/session_01Gg2EYwLr1DXy95Cqm3f4Zk
</commit_message>
<xml_diff>
--- a/presentazione/Tesoreria-Campo-Gedeoni.pptx
+++ b/presentazione/Tesoreria-Campo-Gedeoni.pptx
@@ -108,7 +108,7 @@
   <p:extLst>
     <p:ext uri="{521415D9-36F7-43E2-AB2F-B90AF26B5E84}">
       <p14:sectionLst xmlns:p14="http://schemas.microsoft.com/office/powerpoint/2010/main">
-        <p14:section name="Presentazione" id="{1f2c35e0-4ea8-45ef-84f0-02be9de395e7}">
+        <p14:section name="Presentazione" id="{f7633b08-cba2-b13d-d918-f62c03f4dd52}">
           <p14:sldIdLst>
             <p14:sldId id="256"/>
             <p14:sldId id="257"/>
@@ -684,7 +684,7 @@
     <p:bg>
       <p:bgPr>
         <a:solidFill>
-          <a:srgbClr val="163A69"/>
+          <a:srgbClr val="FFFFFF"/>
         </a:solidFill>
       </p:bgPr>
     </p:bg>
@@ -716,7 +716,7 @@
     <p:bg>
       <p:bgPr>
         <a:solidFill>
-          <a:srgbClr val="163A69"/>
+          <a:srgbClr val="FFFFFF"/>
         </a:solidFill>
       </p:bgPr>
     </p:bg>
@@ -760,7 +760,7 @@
               <a:buNone/>
               <a:defRPr lang="en-US" sz="3000" b="1" dirty="0">
                 <a:solidFill>
-                  <a:schemeClr val="bg1"/>
+                  <a:schemeClr val="tx2"/>
                 </a:solidFill>
               </a:defRPr>
             </a:lvl1pPr>
@@ -772,7 +772,7 @@
             <a:r>
               <a:rPr lang="en-US" sz="3000" b="1" dirty="0">
                 <a:solidFill>
-                  <a:schemeClr val="bg1"/>
+                  <a:schemeClr val="tx2"/>
                 </a:solidFill>
               </a:rPr>
               <a:t>Titolo</a:t>
@@ -832,7 +832,7 @@
             <a:r>
               <a:rPr lang="en-US" sz="900" dirty="0">
                 <a:solidFill>
-                  <a:srgbClr val="8FA3BF"/>
+                  <a:schemeClr val="accent5"/>
                 </a:solidFill>
               </a:rPr>
               <a:t>Tesoreria Campo Gedeoni · campodivittoria.github.io/GideonsTesoreria.app</a:t>
@@ -1196,7 +1196,7 @@
             <a:r>
               <a:rPr lang="en-US" sz="3800" b="1" dirty="0">
                 <a:solidFill>
-                  <a:schemeClr val="bg1"/>
+                  <a:schemeClr val="tx2"/>
                 </a:solidFill>
               </a:rPr>
               <a:t>Tesoreria Campo Gedeoni</a:t>
@@ -1232,7 +1232,7 @@
             <a:r>
               <a:rPr lang="en-US" sz="1600" dirty="0">
                 <a:solidFill>
-                  <a:srgbClr val="CADCFC"/>
+                  <a:schemeClr val="tx1"/>
                 </a:solidFill>
               </a:rPr>
               <a:t>L’app del tesoriere del Campo: una cassa chiara, sempre con sé, con la stessa procedura anno dopo anno.</a:t>
@@ -1258,11 +1258,11 @@
             </a:avLst>
           </a:prstGeom>
           <a:solidFill>
-            <a:srgbClr val="1F4E8C"/>
+            <a:srgbClr val="EEF3FA"/>
           </a:solidFill>
           <a:ln w="12700">
             <a:solidFill>
-              <a:srgbClr val="1F4E8C"/>
+              <a:srgbClr val="EEF3FA"/>
             </a:solidFill>
             <a:prstDash val="solid"/>
           </a:ln>
@@ -1344,7 +1344,7 @@
             <a:r>
               <a:rPr lang="en-US" sz="1500" b="1" dirty="0">
                 <a:solidFill>
-                  <a:schemeClr val="bg1"/>
+                  <a:schemeClr val="tx2"/>
                 </a:solidFill>
               </a:rPr>
               <a:t>Sul telefono</a:t>
@@ -1380,7 +1380,7 @@
             <a:r>
               <a:rPr lang="en-US" sz="1100" dirty="0">
                 <a:solidFill>
-                  <a:srgbClr val="CADCFC"/>
+                  <a:schemeClr val="tx1"/>
                 </a:solidFill>
               </a:rPr>
               <a:t>Si apre dal browser e si aggiunge alla schermata Home: niente installazioni</a:t>
@@ -1406,11 +1406,11 @@
             </a:avLst>
           </a:prstGeom>
           <a:solidFill>
-            <a:srgbClr val="1F4E8C"/>
+            <a:srgbClr val="EEF3FA"/>
           </a:solidFill>
           <a:ln w="12700">
             <a:solidFill>
-              <a:srgbClr val="1F4E8C"/>
+              <a:srgbClr val="EEF3FA"/>
             </a:solidFill>
             <a:prstDash val="solid"/>
           </a:ln>
@@ -1492,7 +1492,7 @@
             <a:r>
               <a:rPr lang="en-US" sz="1500" b="1" dirty="0">
                 <a:solidFill>
-                  <a:schemeClr val="bg1"/>
+                  <a:schemeClr val="tx2"/>
                 </a:solidFill>
               </a:rPr>
               <a:t>Due accessi</a:t>
@@ -1528,7 +1528,7 @@
             <a:r>
               <a:rPr lang="en-US" sz="1100" dirty="0">
                 <a:solidFill>
-                  <a:srgbClr val="CADCFC"/>
+                  <a:schemeClr val="tx1"/>
                 </a:solidFill>
               </a:rPr>
               <a:t>Il tesoriere registra, l’amministratore corregge. Un account di prova per mostrarla</a:t>
@@ -1554,11 +1554,11 @@
             </a:avLst>
           </a:prstGeom>
           <a:solidFill>
-            <a:srgbClr val="1F4E8C"/>
+            <a:srgbClr val="EEF3FA"/>
           </a:solidFill>
           <a:ln w="12700">
             <a:solidFill>
-              <a:srgbClr val="1F4E8C"/>
+              <a:srgbClr val="EEF3FA"/>
             </a:solidFill>
             <a:prstDash val="solid"/>
           </a:ln>
@@ -1640,7 +1640,7 @@
             <a:r>
               <a:rPr lang="en-US" sz="1500" b="1" dirty="0">
                 <a:solidFill>
-                  <a:schemeClr val="bg1"/>
+                  <a:schemeClr val="tx2"/>
                 </a:solidFill>
               </a:rPr>
               <a:t>Anno fiscale</a:t>
@@ -1676,7 +1676,7 @@
             <a:r>
               <a:rPr lang="en-US" sz="1100" dirty="0">
                 <a:solidFill>
-                  <a:srgbClr val="CADCFC"/>
+                  <a:schemeClr val="tx1"/>
                 </a:solidFill>
               </a:rPr>
               <a:t>Dal 1° giugno al 31 maggio: chiusura automatica e riporto dei saldi</a:t>
@@ -1712,7 +1712,7 @@
             <a:r>
               <a:rPr lang="en-US" sz="1000" dirty="0">
                 <a:solidFill>
-                  <a:srgbClr val="8FA3BF"/>
+                  <a:schemeClr val="accent5"/>
                 </a:solidFill>
               </a:rPr>
               <a:t>Versione 3.7 · ottobre 2026</a:t>
@@ -1775,7 +1775,7 @@
             <a:r>
               <a:rPr lang="en-US" sz="3000" b="1" dirty="0">
                 <a:solidFill>
-                  <a:schemeClr val="bg1"/>
+                  <a:schemeClr val="tx2"/>
                 </a:solidFill>
               </a:rPr>
               <a:t>Cosa fa e perché serve al Campo</a:t>
@@ -1799,11 +1799,11 @@
             <a:avLst/>
           </a:prstGeom>
           <a:solidFill>
-            <a:srgbClr val="D9A420"/>
+            <a:srgbClr val="1F4E8C"/>
           </a:solidFill>
           <a:ln w="12700">
             <a:solidFill>
-              <a:srgbClr val="D9A420"/>
+              <a:srgbClr val="1F4E8C"/>
             </a:solidFill>
             <a:prstDash val="solid"/>
           </a:ln>
@@ -1860,7 +1860,7 @@
             <a:r>
               <a:rPr lang="en-US" sz="1500" b="1" dirty="0">
                 <a:solidFill>
-                  <a:schemeClr val="bg1"/>
+                  <a:schemeClr val="tx2"/>
                 </a:solidFill>
               </a:rPr>
               <a:t>Nuova registrazione</a:t>
@@ -1896,7 +1896,7 @@
             <a:r>
               <a:rPr lang="en-US" sz="1100" dirty="0">
                 <a:solidFill>
-                  <a:srgbClr val="CADCFC"/>
+                  <a:schemeClr val="tx1"/>
                 </a:solidFill>
               </a:rPr>
               <a:t>Data, luogo e tutti i conti in un solo foglio: offerte, PWT, Fondo Barnaba, quote annue, Gideons Card, spese</a:t>
@@ -1920,11 +1920,11 @@
             <a:avLst/>
           </a:prstGeom>
           <a:solidFill>
-            <a:srgbClr val="D9A420"/>
+            <a:srgbClr val="1F4E8C"/>
           </a:solidFill>
           <a:ln w="12700">
             <a:solidFill>
-              <a:srgbClr val="D9A420"/>
+              <a:srgbClr val="1F4E8C"/>
             </a:solidFill>
             <a:prstDash val="solid"/>
           </a:ln>
@@ -1981,7 +1981,7 @@
             <a:r>
               <a:rPr lang="en-US" sz="1500" b="1" dirty="0">
                 <a:solidFill>
-                  <a:schemeClr val="bg1"/>
+                  <a:schemeClr val="tx2"/>
                 </a:solidFill>
               </a:rPr>
               <a:t>Riepilogo e Rendiconto</a:t>
@@ -2017,7 +2017,7 @@
             <a:r>
               <a:rPr lang="en-US" sz="1100" dirty="0">
                 <a:solidFill>
-                  <a:srgbClr val="CADCFC"/>
+                  <a:schemeClr val="tx1"/>
                 </a:solidFill>
               </a:rPr>
               <a:t>Grafico della cassa, saldo di ogni conto, Pro Campo separato dagli altri; stampabile</a:t>
@@ -2041,11 +2041,11 @@
             <a:avLst/>
           </a:prstGeom>
           <a:solidFill>
-            <a:srgbClr val="D9A420"/>
+            <a:srgbClr val="1F4E8C"/>
           </a:solidFill>
           <a:ln w="12700">
             <a:solidFill>
-              <a:srgbClr val="D9A420"/>
+              <a:srgbClr val="1F4E8C"/>
             </a:solidFill>
             <a:prstDash val="solid"/>
           </a:ln>
@@ -2102,7 +2102,7 @@
             <a:r>
               <a:rPr lang="en-US" sz="1500" b="1" dirty="0">
                 <a:solidFill>
-                  <a:schemeClr val="bg1"/>
+                  <a:schemeClr val="tx2"/>
                 </a:solidFill>
               </a:rPr>
               <a:t>Storico e Bilancio</a:t>
@@ -2138,7 +2138,7 @@
             <a:r>
               <a:rPr lang="en-US" sz="1100" dirty="0">
                 <a:solidFill>
-                  <a:srgbClr val="CADCFC"/>
+                  <a:schemeClr val="tx1"/>
                 </a:solidFill>
               </a:rPr>
               <a:t>Tutte le registrazioni nel tempo e un bilancio archiviato per ogni anno fiscale</a:t>
@@ -2162,11 +2162,11 @@
             <a:avLst/>
           </a:prstGeom>
           <a:solidFill>
-            <a:srgbClr val="D9A420"/>
+            <a:srgbClr val="1F4E8C"/>
           </a:solidFill>
           <a:ln w="12700">
             <a:solidFill>
-              <a:srgbClr val="D9A420"/>
+              <a:srgbClr val="1F4E8C"/>
             </a:solidFill>
             <a:prstDash val="solid"/>
           </a:ln>
@@ -2223,7 +2223,7 @@
             <a:r>
               <a:rPr lang="en-US" sz="1500" b="1" dirty="0">
                 <a:solidFill>
-                  <a:schemeClr val="bg1"/>
+                  <a:schemeClr val="tx2"/>
                 </a:solidFill>
               </a:rPr>
               <a:t>Chiusura Cassa</a:t>
@@ -2259,7 +2259,7 @@
             <a:r>
               <a:rPr lang="en-US" sz="1100" dirty="0">
                 <a:solidFill>
-                  <a:srgbClr val="CADCFC"/>
+                  <a:schemeClr val="tx1"/>
                 </a:solidFill>
               </a:rPr>
               <a:t>Bonifico di fine anno con data, esecutore e banca; i saldi residui diventano il riporto</a:t>
@@ -2285,11 +2285,11 @@
             </a:avLst>
           </a:prstGeom>
           <a:solidFill>
-            <a:srgbClr val="1F4E8C"/>
+            <a:srgbClr val="EEF3FA"/>
           </a:solidFill>
           <a:ln w="12700">
             <a:solidFill>
-              <a:srgbClr val="1F4E8C"/>
+              <a:srgbClr val="EEF3FA"/>
             </a:solidFill>
             <a:prstDash val="solid"/>
           </a:ln>
@@ -2322,7 +2322,7 @@
             <a:r>
               <a:rPr lang="en-US" sz="1700" b="1" dirty="0">
                 <a:solidFill>
-                  <a:schemeClr val="bg1"/>
+                  <a:schemeClr val="tx2"/>
                 </a:solidFill>
               </a:rPr>
               <a:t>Perché serve</a:t>
@@ -2407,7 +2407,7 @@
             <a:r>
               <a:rPr lang="en-US" sz="1300" b="1" dirty="0">
                 <a:solidFill>
-                  <a:schemeClr val="bg1"/>
+                  <a:schemeClr val="tx2"/>
                 </a:solidFill>
               </a:rPr>
               <a:t>Contabilità interna chiara</a:t>
@@ -2443,7 +2443,7 @@
             <a:r>
               <a:rPr lang="en-US" sz="1050" dirty="0">
                 <a:solidFill>
-                  <a:srgbClr val="CADCFC"/>
+                  <a:schemeClr val="tx1"/>
                 </a:solidFill>
               </a:rPr>
               <a:t>Ogni euro raccolto nelle riunioni e nelle chiese ha una data, un luogo e un conto. Niente più fogli sparsi.</a:t>
@@ -2528,7 +2528,7 @@
             <a:r>
               <a:rPr lang="en-US" sz="1300" b="1" dirty="0">
                 <a:solidFill>
-                  <a:schemeClr val="bg1"/>
+                  <a:schemeClr val="tx2"/>
                 </a:solidFill>
               </a:rPr>
               <a:t>Passaggio tra tesorieri</a:t>
@@ -2564,7 +2564,7 @@
             <a:r>
               <a:rPr lang="en-US" sz="1050" dirty="0">
                 <a:solidFill>
-                  <a:srgbClr val="CADCFC"/>
+                  <a:schemeClr val="tx1"/>
                 </a:solidFill>
               </a:rPr>
               <a:t>Ogni tre anni il tesoriere cambia: con l’app il nuovo tesoriere trova gli stessi conti, la stessa procedura e lo storico completo. Nulla va perso nella transizione.</a:t>

</xml_diff>

<commit_message>
Presentazione: link ipertestuale all'app su entrambe le slide
Co-Authored-By: Claude Fable 5.1 <noreply@anthropic.com>
Claude-Session: https://claude.ai/code/session_01Gg2EYwLr1DXy95Cqm3f4Zk
</commit_message>
<xml_diff>
--- a/presentazione/Tesoreria-Campo-Gedeoni.pptx
+++ b/presentazione/Tesoreria-Campo-Gedeoni.pptx
@@ -108,7 +108,7 @@
   <p:extLst>
     <p:ext uri="{521415D9-36F7-43E2-AB2F-B90AF26B5E84}">
       <p14:sectionLst xmlns:p14="http://schemas.microsoft.com/office/powerpoint/2010/main">
-        <p14:section name="Presentazione" id="{f7633b08-cba2-b13d-d918-f62c03f4dd52}">
+        <p14:section name="Presentazione" id="{96e39be9-0415-43cf-2a63-cf85fed7f294}">
           <p14:sldIdLst>
             <p14:sldId id="256"/>
             <p14:sldId id="257"/>
@@ -781,66 +781,6 @@
           </a:p>
         </p:txBody>
       </p:sp>
-      <p:pic>
-        <p:nvPicPr>
-          <p:cNvPr id="3" name="Image 0" descr="preencoded.png">    </p:cNvPr>
-          <p:cNvPicPr>
-            <a:picLocks noChangeAspect="1"/>
-          </p:cNvPicPr>
-          <p:nvPr/>
-        </p:nvPicPr>
-        <p:blipFill>
-          <a:blip r:embed="rId1"/>
-          <a:stretch>
-            <a:fillRect/>
-          </a:stretch>
-        </p:blipFill>
-        <p:spPr>
-          <a:xfrm>
-            <a:off x="8366760" y="4572000"/>
-            <a:ext cx="365760" cy="365760"/>
-          </a:xfrm>
-          <a:prstGeom prst="rect">
-            <a:avLst/>
-          </a:prstGeom>
-        </p:spPr>
-      </p:pic>
-      <p:sp>
-        <p:nvSpPr>
-          <p:cNvPr id="4" name="Text 0"/>
-          <p:cNvSpPr/>
-          <p:nvPr/>
-        </p:nvSpPr>
-        <p:spPr>
-          <a:xfrm>
-            <a:off x="457200" y="4617720"/>
-            <a:ext cx="7680960" cy="274320"/>
-          </a:xfrm>
-          <a:prstGeom prst="rect">
-            <a:avLst/>
-          </a:prstGeom>
-          <a:noFill/>
-          <a:ln/>
-        </p:spPr>
-        <p:txBody>
-          <a:bodyPr wrap="square" lIns="0" tIns="0" rIns="0" bIns="0" rtlCol="0" anchor="ctr"/>
-          <a:lstStyle/>
-          <a:p>
-            <a:pPr indent="0" marL="0">
-              <a:buNone/>
-            </a:pPr>
-            <a:r>
-              <a:rPr lang="en-US" sz="900" dirty="0">
-                <a:solidFill>
-                  <a:schemeClr val="accent5"/>
-                </a:solidFill>
-              </a:rPr>
-              <a:t>Tesoreria Campo Gedeoni · campodivittoria.github.io/GideonsTesoreria.app</a:t>
-            </a:r>
-            <a:endParaRPr lang="en-US" sz="900" dirty="0"/>
-          </a:p>
-        </p:txBody>
-      </p:sp>
     </p:spTree>
   </p:cSld>
   <p:clrMapOvr>
@@ -1147,7 +1087,9 @@
       </p:grpSpPr>
       <p:pic>
         <p:nvPicPr>
-          <p:cNvPr id="2" name="Logo app" descr="preencoded.png">    </p:cNvPr>
+          <p:cNvPr id="2" name="Logo app" descr="preencoded.png">
+            <a:hlinkClick r:id="rId2" tooltip="Apri l’app Tesoreria Campo Gedeoni"/>
+          </p:cNvPr>
           <p:cNvPicPr>
             <a:picLocks noChangeAspect="1"/>
           </p:cNvPicPr>
@@ -1214,7 +1156,7 @@
         <p:spPr>
           <a:xfrm>
             <a:off x="3108960" y="1783080"/>
-            <a:ext cx="5486400" cy="914400"/>
+            <a:ext cx="5486400" cy="777240"/>
           </a:xfrm>
           <a:prstGeom prst="rect">
             <a:avLst/>
@@ -1243,7 +1185,61 @@
       </p:sp>
       <p:sp>
         <p:nvSpPr>
-          <p:cNvPr id="5" name="Riquadro Sul telefono"/>
+          <p:cNvPr id="5" name="Link app"/>
+          <p:cNvSpPr txBox="1"/>
+          <p:nvPr/>
+        </p:nvSpPr>
+        <p:spPr>
+          <a:xfrm>
+            <a:off x="3108960" y="2606040"/>
+            <a:ext cx="5486400" cy="365760"/>
+          </a:xfrm>
+          <a:prstGeom prst="rect">
+            <a:avLst/>
+          </a:prstGeom>
+          <a:noFill/>
+          <a:ln/>
+        </p:spPr>
+        <p:txBody>
+          <a:bodyPr wrap="square" lIns="0" tIns="0" rIns="0" bIns="0" rtlCol="0" anchor="t"/>
+          <a:lstStyle/>
+          <a:p>
+            <a:pPr indent="0" marL="0">
+              <a:buNone/>
+            </a:pPr>
+            <a:r>
+              <a:rPr lang="en-US" sz="1400" dirty="0">
+                <a:solidFill>
+                  <a:schemeClr val="tx1"/>
+                </a:solidFill>
+              </a:rPr>
+              <a:t>Apri l’app: </a:t>
+            </a:r>
+            <a:pPr indent="0" marL="0">
+              <a:buNone/>
+            </a:pPr>
+            <a:r>
+              <a:rPr lang="en-US" sz="1400" u="sng" dirty="0">
+                <a:solidFill>
+                  <a:schemeClr val="accent1"/>
+                </a:solidFill>
+                <a:hlinkClick r:id="rId3" invalidUrl="" action="" tgtFrame="" tooltip="Apri l’app Tesoreria Campo Gedeoni" history="1" highlightClick="0" endSnd="0">
+                  <a:extLst>
+                    <a:ext uri="{A12FA001-AC4F-418D-AE19-62706E023703}">
+                      <ahyp:hlinkClr xmlns:ahyp="http://schemas.microsoft.com/office/drawing/2018/hyperlinkcolor" val="tx"/>
+                    </a:ext>
+                  </a:extLst>
+                </a:hlinkClick>
+              </a:rPr>
+              <a:t>campodivittoria.github.io/GideonsTesoreria.app</a:t>
+            </a:r>
+            <a:endParaRPr lang="en-US" sz="1400" dirty="0"/>
+          </a:p>
+        </p:txBody>
+      </p:sp>
+      <p:sp>
+        <p:nvSpPr>
+          <p:cNvPr id="6" name="Riquadro Sul telefono"/>
           <p:cNvSpPr/>
           <p:nvPr/>
         </p:nvSpPr>
@@ -1270,7 +1266,7 @@
       </p:sp>
       <p:sp>
         <p:nvSpPr>
-          <p:cNvPr id="6" name="Cerchio icona Sul telefono"/>
+          <p:cNvPr id="7" name="Cerchio icona Sul telefono"/>
           <p:cNvSpPr/>
           <p:nvPr/>
         </p:nvSpPr>
@@ -1295,303 +1291,7 @@
       </p:sp>
       <p:pic>
         <p:nvPicPr>
-          <p:cNvPr id="7" name="Icona Sul telefono" descr="preencoded.png">    </p:cNvPr>
-          <p:cNvPicPr>
-            <a:picLocks noChangeAspect="1"/>
-          </p:cNvPicPr>
-          <p:nvPr/>
-        </p:nvPicPr>
-        <p:blipFill>
-          <a:blip r:embed="rId2"/>
-          <a:stretch>
-            <a:fillRect/>
-          </a:stretch>
-        </p:blipFill>
-        <p:spPr>
-          <a:xfrm>
-            <a:off x="905256" y="3502152"/>
-            <a:ext cx="256032" cy="256032"/>
-          </a:xfrm>
-          <a:prstGeom prst="rect">
-            <a:avLst/>
-          </a:prstGeom>
-        </p:spPr>
-      </p:pic>
-      <p:sp>
-        <p:nvSpPr>
-          <p:cNvPr id="8" name="Titolo Sul telefono"/>
-          <p:cNvSpPr txBox="1"/>
-          <p:nvPr/>
-        </p:nvSpPr>
-        <p:spPr>
-          <a:xfrm>
-            <a:off x="1371600" y="3383280"/>
-            <a:ext cx="1691640" cy="457200"/>
-          </a:xfrm>
-          <a:prstGeom prst="rect">
-            <a:avLst/>
-          </a:prstGeom>
-          <a:noFill/>
-          <a:ln/>
-        </p:spPr>
-        <p:txBody>
-          <a:bodyPr wrap="square" lIns="0" tIns="0" rIns="0" bIns="0" rtlCol="0" anchor="ctr"/>
-          <a:lstStyle/>
-          <a:p>
-            <a:pPr indent="0" marL="0">
-              <a:buNone/>
-            </a:pPr>
-            <a:r>
-              <a:rPr lang="en-US" sz="1500" b="1" dirty="0">
-                <a:solidFill>
-                  <a:schemeClr val="tx2"/>
-                </a:solidFill>
-              </a:rPr>
-              <a:t>Sul telefono</a:t>
-            </a:r>
-            <a:endParaRPr lang="en-US" sz="1500" dirty="0"/>
-          </a:p>
-        </p:txBody>
-      </p:sp>
-      <p:sp>
-        <p:nvSpPr>
-          <p:cNvPr id="9" name="Testo Sul telefono"/>
-          <p:cNvSpPr txBox="1"/>
-          <p:nvPr/>
-        </p:nvSpPr>
-        <p:spPr>
-          <a:xfrm>
-            <a:off x="804672" y="3931920"/>
-            <a:ext cx="2240280" cy="685800"/>
-          </a:xfrm>
-          <a:prstGeom prst="rect">
-            <a:avLst/>
-          </a:prstGeom>
-          <a:noFill/>
-          <a:ln/>
-        </p:spPr>
-        <p:txBody>
-          <a:bodyPr wrap="square" lIns="0" tIns="0" rIns="0" bIns="0" rtlCol="0" anchor="t"/>
-          <a:lstStyle/>
-          <a:p>
-            <a:pPr indent="0" marL="0">
-              <a:buNone/>
-            </a:pPr>
-            <a:r>
-              <a:rPr lang="en-US" sz="1100" dirty="0">
-                <a:solidFill>
-                  <a:schemeClr val="tx1"/>
-                </a:solidFill>
-              </a:rPr>
-              <a:t>Si apre dal browser e si aggiunge alla schermata Home: niente installazioni</a:t>
-            </a:r>
-            <a:endParaRPr lang="en-US" sz="1100" dirty="0"/>
-          </a:p>
-        </p:txBody>
-      </p:sp>
-      <p:sp>
-        <p:nvSpPr>
-          <p:cNvPr id="10" name="Riquadro Due accessi"/>
-          <p:cNvSpPr/>
-          <p:nvPr/>
-        </p:nvSpPr>
-        <p:spPr>
-          <a:xfrm>
-            <a:off x="3383280" y="3246120"/>
-            <a:ext cx="2514600" cy="1417320"/>
-          </a:xfrm>
-          <a:prstGeom prst="roundRect">
-            <a:avLst>
-              <a:gd name="adj" fmla="val 7742"/>
-            </a:avLst>
-          </a:prstGeom>
-          <a:solidFill>
-            <a:srgbClr val="EEF3FA"/>
-          </a:solidFill>
-          <a:ln w="12700">
-            <a:solidFill>
-              <a:srgbClr val="EEF3FA"/>
-            </a:solidFill>
-            <a:prstDash val="solid"/>
-          </a:ln>
-        </p:spPr>
-      </p:sp>
-      <p:sp>
-        <p:nvSpPr>
-          <p:cNvPr id="11" name="Cerchio icona Due accessi"/>
-          <p:cNvSpPr/>
-          <p:nvPr/>
-        </p:nvSpPr>
-        <p:spPr>
-          <a:xfrm>
-            <a:off x="3547872" y="3401568"/>
-            <a:ext cx="457200" cy="457200"/>
-          </a:xfrm>
-          <a:prstGeom prst="ellipse">
-            <a:avLst/>
-          </a:prstGeom>
-          <a:solidFill>
-            <a:srgbClr val="D9A420"/>
-          </a:solidFill>
-          <a:ln w="12700">
-            <a:solidFill>
-              <a:srgbClr val="D9A420"/>
-            </a:solidFill>
-            <a:prstDash val="solid"/>
-          </a:ln>
-        </p:spPr>
-      </p:sp>
-      <p:pic>
-        <p:nvPicPr>
-          <p:cNvPr id="12" name="Icona Due accessi" descr="preencoded.png">    </p:cNvPr>
-          <p:cNvPicPr>
-            <a:picLocks noChangeAspect="1"/>
-          </p:cNvPicPr>
-          <p:nvPr/>
-        </p:nvPicPr>
-        <p:blipFill>
-          <a:blip r:embed="rId3"/>
-          <a:stretch>
-            <a:fillRect/>
-          </a:stretch>
-        </p:blipFill>
-        <p:spPr>
-          <a:xfrm>
-            <a:off x="3648456" y="3502152"/>
-            <a:ext cx="256032" cy="256032"/>
-          </a:xfrm>
-          <a:prstGeom prst="rect">
-            <a:avLst/>
-          </a:prstGeom>
-        </p:spPr>
-      </p:pic>
-      <p:sp>
-        <p:nvSpPr>
-          <p:cNvPr id="13" name="Titolo Due accessi"/>
-          <p:cNvSpPr txBox="1"/>
-          <p:nvPr/>
-        </p:nvSpPr>
-        <p:spPr>
-          <a:xfrm>
-            <a:off x="4114800" y="3383280"/>
-            <a:ext cx="1691640" cy="457200"/>
-          </a:xfrm>
-          <a:prstGeom prst="rect">
-            <a:avLst/>
-          </a:prstGeom>
-          <a:noFill/>
-          <a:ln/>
-        </p:spPr>
-        <p:txBody>
-          <a:bodyPr wrap="square" lIns="0" tIns="0" rIns="0" bIns="0" rtlCol="0" anchor="ctr"/>
-          <a:lstStyle/>
-          <a:p>
-            <a:pPr indent="0" marL="0">
-              <a:buNone/>
-            </a:pPr>
-            <a:r>
-              <a:rPr lang="en-US" sz="1500" b="1" dirty="0">
-                <a:solidFill>
-                  <a:schemeClr val="tx2"/>
-                </a:solidFill>
-              </a:rPr>
-              <a:t>Due accessi</a:t>
-            </a:r>
-            <a:endParaRPr lang="en-US" sz="1500" dirty="0"/>
-          </a:p>
-        </p:txBody>
-      </p:sp>
-      <p:sp>
-        <p:nvSpPr>
-          <p:cNvPr id="14" name="Testo Due accessi"/>
-          <p:cNvSpPr txBox="1"/>
-          <p:nvPr/>
-        </p:nvSpPr>
-        <p:spPr>
-          <a:xfrm>
-            <a:off x="3547872" y="3931920"/>
-            <a:ext cx="2240280" cy="685800"/>
-          </a:xfrm>
-          <a:prstGeom prst="rect">
-            <a:avLst/>
-          </a:prstGeom>
-          <a:noFill/>
-          <a:ln/>
-        </p:spPr>
-        <p:txBody>
-          <a:bodyPr wrap="square" lIns="0" tIns="0" rIns="0" bIns="0" rtlCol="0" anchor="t"/>
-          <a:lstStyle/>
-          <a:p>
-            <a:pPr indent="0" marL="0">
-              <a:buNone/>
-            </a:pPr>
-            <a:r>
-              <a:rPr lang="en-US" sz="1100" dirty="0">
-                <a:solidFill>
-                  <a:schemeClr val="tx1"/>
-                </a:solidFill>
-              </a:rPr>
-              <a:t>Il tesoriere registra, l’amministratore corregge. Un account di prova per mostrarla</a:t>
-            </a:r>
-            <a:endParaRPr lang="en-US" sz="1100" dirty="0"/>
-          </a:p>
-        </p:txBody>
-      </p:sp>
-      <p:sp>
-        <p:nvSpPr>
-          <p:cNvPr id="15" name="Riquadro Anno fiscale"/>
-          <p:cNvSpPr/>
-          <p:nvPr/>
-        </p:nvSpPr>
-        <p:spPr>
-          <a:xfrm>
-            <a:off x="6126480" y="3246120"/>
-            <a:ext cx="2514600" cy="1417320"/>
-          </a:xfrm>
-          <a:prstGeom prst="roundRect">
-            <a:avLst>
-              <a:gd name="adj" fmla="val 7742"/>
-            </a:avLst>
-          </a:prstGeom>
-          <a:solidFill>
-            <a:srgbClr val="EEF3FA"/>
-          </a:solidFill>
-          <a:ln w="12700">
-            <a:solidFill>
-              <a:srgbClr val="EEF3FA"/>
-            </a:solidFill>
-            <a:prstDash val="solid"/>
-          </a:ln>
-        </p:spPr>
-      </p:sp>
-      <p:sp>
-        <p:nvSpPr>
-          <p:cNvPr id="16" name="Cerchio icona Anno fiscale"/>
-          <p:cNvSpPr/>
-          <p:nvPr/>
-        </p:nvSpPr>
-        <p:spPr>
-          <a:xfrm>
-            <a:off x="6291072" y="3401568"/>
-            <a:ext cx="457200" cy="457200"/>
-          </a:xfrm>
-          <a:prstGeom prst="ellipse">
-            <a:avLst/>
-          </a:prstGeom>
-          <a:solidFill>
-            <a:srgbClr val="D9A420"/>
-          </a:solidFill>
-          <a:ln w="12700">
-            <a:solidFill>
-              <a:srgbClr val="D9A420"/>
-            </a:solidFill>
-            <a:prstDash val="solid"/>
-          </a:ln>
-        </p:spPr>
-      </p:sp>
-      <p:pic>
-        <p:nvPicPr>
-          <p:cNvPr id="17" name="Icona Anno fiscale" descr="preencoded.png">    </p:cNvPr>
+          <p:cNvPr id="8" name="Icona Sul telefono" descr="preencoded.png">    </p:cNvPr>
           <p:cNvPicPr>
             <a:picLocks noChangeAspect="1"/>
           </p:cNvPicPr>
@@ -1605,6 +1305,302 @@
         </p:blipFill>
         <p:spPr>
           <a:xfrm>
+            <a:off x="905256" y="3502152"/>
+            <a:ext cx="256032" cy="256032"/>
+          </a:xfrm>
+          <a:prstGeom prst="rect">
+            <a:avLst/>
+          </a:prstGeom>
+        </p:spPr>
+      </p:pic>
+      <p:sp>
+        <p:nvSpPr>
+          <p:cNvPr id="9" name="Titolo Sul telefono"/>
+          <p:cNvSpPr txBox="1"/>
+          <p:nvPr/>
+        </p:nvSpPr>
+        <p:spPr>
+          <a:xfrm>
+            <a:off x="1371600" y="3383280"/>
+            <a:ext cx="1691640" cy="457200"/>
+          </a:xfrm>
+          <a:prstGeom prst="rect">
+            <a:avLst/>
+          </a:prstGeom>
+          <a:noFill/>
+          <a:ln/>
+        </p:spPr>
+        <p:txBody>
+          <a:bodyPr wrap="square" lIns="0" tIns="0" rIns="0" bIns="0" rtlCol="0" anchor="ctr"/>
+          <a:lstStyle/>
+          <a:p>
+            <a:pPr indent="0" marL="0">
+              <a:buNone/>
+            </a:pPr>
+            <a:r>
+              <a:rPr lang="en-US" sz="1500" b="1" dirty="0">
+                <a:solidFill>
+                  <a:schemeClr val="tx2"/>
+                </a:solidFill>
+              </a:rPr>
+              <a:t>Sul telefono</a:t>
+            </a:r>
+            <a:endParaRPr lang="en-US" sz="1500" dirty="0"/>
+          </a:p>
+        </p:txBody>
+      </p:sp>
+      <p:sp>
+        <p:nvSpPr>
+          <p:cNvPr id="10" name="Testo Sul telefono"/>
+          <p:cNvSpPr txBox="1"/>
+          <p:nvPr/>
+        </p:nvSpPr>
+        <p:spPr>
+          <a:xfrm>
+            <a:off x="804672" y="3931920"/>
+            <a:ext cx="2240280" cy="685800"/>
+          </a:xfrm>
+          <a:prstGeom prst="rect">
+            <a:avLst/>
+          </a:prstGeom>
+          <a:noFill/>
+          <a:ln/>
+        </p:spPr>
+        <p:txBody>
+          <a:bodyPr wrap="square" lIns="0" tIns="0" rIns="0" bIns="0" rtlCol="0" anchor="t"/>
+          <a:lstStyle/>
+          <a:p>
+            <a:pPr indent="0" marL="0">
+              <a:buNone/>
+            </a:pPr>
+            <a:r>
+              <a:rPr lang="en-US" sz="1100" dirty="0">
+                <a:solidFill>
+                  <a:schemeClr val="tx1"/>
+                </a:solidFill>
+              </a:rPr>
+              <a:t>Si apre dal browser e si aggiunge alla schermata Home: niente installazioni</a:t>
+            </a:r>
+            <a:endParaRPr lang="en-US" sz="1100" dirty="0"/>
+          </a:p>
+        </p:txBody>
+      </p:sp>
+      <p:sp>
+        <p:nvSpPr>
+          <p:cNvPr id="11" name="Riquadro Due accessi"/>
+          <p:cNvSpPr/>
+          <p:nvPr/>
+        </p:nvSpPr>
+        <p:spPr>
+          <a:xfrm>
+            <a:off x="3383280" y="3246120"/>
+            <a:ext cx="2514600" cy="1417320"/>
+          </a:xfrm>
+          <a:prstGeom prst="roundRect">
+            <a:avLst>
+              <a:gd name="adj" fmla="val 7742"/>
+            </a:avLst>
+          </a:prstGeom>
+          <a:solidFill>
+            <a:srgbClr val="EEF3FA"/>
+          </a:solidFill>
+          <a:ln w="12700">
+            <a:solidFill>
+              <a:srgbClr val="EEF3FA"/>
+            </a:solidFill>
+            <a:prstDash val="solid"/>
+          </a:ln>
+        </p:spPr>
+      </p:sp>
+      <p:sp>
+        <p:nvSpPr>
+          <p:cNvPr id="12" name="Cerchio icona Due accessi"/>
+          <p:cNvSpPr/>
+          <p:nvPr/>
+        </p:nvSpPr>
+        <p:spPr>
+          <a:xfrm>
+            <a:off x="3547872" y="3401568"/>
+            <a:ext cx="457200" cy="457200"/>
+          </a:xfrm>
+          <a:prstGeom prst="ellipse">
+            <a:avLst/>
+          </a:prstGeom>
+          <a:solidFill>
+            <a:srgbClr val="D9A420"/>
+          </a:solidFill>
+          <a:ln w="12700">
+            <a:solidFill>
+              <a:srgbClr val="D9A420"/>
+            </a:solidFill>
+            <a:prstDash val="solid"/>
+          </a:ln>
+        </p:spPr>
+      </p:sp>
+      <p:pic>
+        <p:nvPicPr>
+          <p:cNvPr id="13" name="Icona Due accessi" descr="preencoded.png">    </p:cNvPr>
+          <p:cNvPicPr>
+            <a:picLocks noChangeAspect="1"/>
+          </p:cNvPicPr>
+          <p:nvPr/>
+        </p:nvPicPr>
+        <p:blipFill>
+          <a:blip r:embed="rId5"/>
+          <a:stretch>
+            <a:fillRect/>
+          </a:stretch>
+        </p:blipFill>
+        <p:spPr>
+          <a:xfrm>
+            <a:off x="3648456" y="3502152"/>
+            <a:ext cx="256032" cy="256032"/>
+          </a:xfrm>
+          <a:prstGeom prst="rect">
+            <a:avLst/>
+          </a:prstGeom>
+        </p:spPr>
+      </p:pic>
+      <p:sp>
+        <p:nvSpPr>
+          <p:cNvPr id="14" name="Titolo Due accessi"/>
+          <p:cNvSpPr txBox="1"/>
+          <p:nvPr/>
+        </p:nvSpPr>
+        <p:spPr>
+          <a:xfrm>
+            <a:off x="4114800" y="3383280"/>
+            <a:ext cx="1691640" cy="457200"/>
+          </a:xfrm>
+          <a:prstGeom prst="rect">
+            <a:avLst/>
+          </a:prstGeom>
+          <a:noFill/>
+          <a:ln/>
+        </p:spPr>
+        <p:txBody>
+          <a:bodyPr wrap="square" lIns="0" tIns="0" rIns="0" bIns="0" rtlCol="0" anchor="ctr"/>
+          <a:lstStyle/>
+          <a:p>
+            <a:pPr indent="0" marL="0">
+              <a:buNone/>
+            </a:pPr>
+            <a:r>
+              <a:rPr lang="en-US" sz="1500" b="1" dirty="0">
+                <a:solidFill>
+                  <a:schemeClr val="tx2"/>
+                </a:solidFill>
+              </a:rPr>
+              <a:t>Due accessi</a:t>
+            </a:r>
+            <a:endParaRPr lang="en-US" sz="1500" dirty="0"/>
+          </a:p>
+        </p:txBody>
+      </p:sp>
+      <p:sp>
+        <p:nvSpPr>
+          <p:cNvPr id="15" name="Testo Due accessi"/>
+          <p:cNvSpPr txBox="1"/>
+          <p:nvPr/>
+        </p:nvSpPr>
+        <p:spPr>
+          <a:xfrm>
+            <a:off x="3547872" y="3931920"/>
+            <a:ext cx="2240280" cy="685800"/>
+          </a:xfrm>
+          <a:prstGeom prst="rect">
+            <a:avLst/>
+          </a:prstGeom>
+          <a:noFill/>
+          <a:ln/>
+        </p:spPr>
+        <p:txBody>
+          <a:bodyPr wrap="square" lIns="0" tIns="0" rIns="0" bIns="0" rtlCol="0" anchor="t"/>
+          <a:lstStyle/>
+          <a:p>
+            <a:pPr indent="0" marL="0">
+              <a:buNone/>
+            </a:pPr>
+            <a:r>
+              <a:rPr lang="en-US" sz="1100" dirty="0">
+                <a:solidFill>
+                  <a:schemeClr val="tx1"/>
+                </a:solidFill>
+              </a:rPr>
+              <a:t>Il tesoriere registra, l’amministratore corregge. Un account di prova per mostrarla</a:t>
+            </a:r>
+            <a:endParaRPr lang="en-US" sz="1100" dirty="0"/>
+          </a:p>
+        </p:txBody>
+      </p:sp>
+      <p:sp>
+        <p:nvSpPr>
+          <p:cNvPr id="16" name="Riquadro Anno fiscale"/>
+          <p:cNvSpPr/>
+          <p:nvPr/>
+        </p:nvSpPr>
+        <p:spPr>
+          <a:xfrm>
+            <a:off x="6126480" y="3246120"/>
+            <a:ext cx="2514600" cy="1417320"/>
+          </a:xfrm>
+          <a:prstGeom prst="roundRect">
+            <a:avLst>
+              <a:gd name="adj" fmla="val 7742"/>
+            </a:avLst>
+          </a:prstGeom>
+          <a:solidFill>
+            <a:srgbClr val="EEF3FA"/>
+          </a:solidFill>
+          <a:ln w="12700">
+            <a:solidFill>
+              <a:srgbClr val="EEF3FA"/>
+            </a:solidFill>
+            <a:prstDash val="solid"/>
+          </a:ln>
+        </p:spPr>
+      </p:sp>
+      <p:sp>
+        <p:nvSpPr>
+          <p:cNvPr id="17" name="Cerchio icona Anno fiscale"/>
+          <p:cNvSpPr/>
+          <p:nvPr/>
+        </p:nvSpPr>
+        <p:spPr>
+          <a:xfrm>
+            <a:off x="6291072" y="3401568"/>
+            <a:ext cx="457200" cy="457200"/>
+          </a:xfrm>
+          <a:prstGeom prst="ellipse">
+            <a:avLst/>
+          </a:prstGeom>
+          <a:solidFill>
+            <a:srgbClr val="D9A420"/>
+          </a:solidFill>
+          <a:ln w="12700">
+            <a:solidFill>
+              <a:srgbClr val="D9A420"/>
+            </a:solidFill>
+            <a:prstDash val="solid"/>
+          </a:ln>
+        </p:spPr>
+      </p:sp>
+      <p:pic>
+        <p:nvPicPr>
+          <p:cNvPr id="18" name="Icona Anno fiscale" descr="preencoded.png">    </p:cNvPr>
+          <p:cNvPicPr>
+            <a:picLocks noChangeAspect="1"/>
+          </p:cNvPicPr>
+          <p:nvPr/>
+        </p:nvPicPr>
+        <p:blipFill>
+          <a:blip r:embed="rId6"/>
+          <a:stretch>
+            <a:fillRect/>
+          </a:stretch>
+        </p:blipFill>
+        <p:spPr>
+          <a:xfrm>
             <a:off x="6391656" y="3502152"/>
             <a:ext cx="256032" cy="256032"/>
           </a:xfrm>
@@ -1615,7 +1611,7 @@
       </p:pic>
       <p:sp>
         <p:nvSpPr>
-          <p:cNvPr id="18" name="Titolo Anno fiscale"/>
+          <p:cNvPr id="19" name="Titolo Anno fiscale"/>
           <p:cNvSpPr txBox="1"/>
           <p:nvPr/>
         </p:nvSpPr>
@@ -1651,7 +1647,7 @@
       </p:sp>
       <p:sp>
         <p:nvSpPr>
-          <p:cNvPr id="19" name="Testo Anno fiscale"/>
+          <p:cNvPr id="20" name="Testo Anno fiscale"/>
           <p:cNvSpPr txBox="1"/>
           <p:nvPr/>
         </p:nvSpPr>
@@ -1687,7 +1683,7 @@
       </p:sp>
       <p:sp>
         <p:nvSpPr>
-          <p:cNvPr id="20" name="Versione"/>
+          <p:cNvPr id="21" name="Versione"/>
           <p:cNvSpPr txBox="1"/>
           <p:nvPr/>
         </p:nvSpPr>
@@ -2573,6 +2569,86 @@
           </a:p>
         </p:txBody>
       </p:sp>
+      <p:sp>
+        <p:nvSpPr>
+          <p:cNvPr id="29" name="Piè di pagina con link"/>
+          <p:cNvSpPr txBox="1"/>
+          <p:nvPr/>
+        </p:nvSpPr>
+        <p:spPr>
+          <a:xfrm>
+            <a:off x="457200" y="4617720"/>
+            <a:ext cx="7680960" cy="274320"/>
+          </a:xfrm>
+          <a:prstGeom prst="rect">
+            <a:avLst/>
+          </a:prstGeom>
+          <a:noFill/>
+          <a:ln/>
+        </p:spPr>
+        <p:txBody>
+          <a:bodyPr wrap="square" lIns="0" tIns="0" rIns="0" bIns="0" rtlCol="0" anchor="ctr"/>
+          <a:lstStyle/>
+          <a:p>
+            <a:pPr indent="0" marL="0">
+              <a:buNone/>
+            </a:pPr>
+            <a:r>
+              <a:rPr lang="en-US" sz="900" dirty="0">
+                <a:solidFill>
+                  <a:schemeClr val="accent5"/>
+                </a:solidFill>
+              </a:rPr>
+              <a:t>Tesoreria Campo Gedeoni · </a:t>
+            </a:r>
+            <a:pPr indent="0" marL="0">
+              <a:buNone/>
+            </a:pPr>
+            <a:r>
+              <a:rPr lang="en-US" sz="900" u="sng" dirty="0">
+                <a:solidFill>
+                  <a:schemeClr val="accent1"/>
+                </a:solidFill>
+                <a:hlinkClick r:id="rId7" invalidUrl="" action="" tgtFrame="" tooltip="Apri l’app Tesoreria Campo Gedeoni" history="1" highlightClick="0" endSnd="0">
+                  <a:extLst>
+                    <a:ext uri="{A12FA001-AC4F-418D-AE19-62706E023703}">
+                      <ahyp:hlinkClr xmlns:ahyp="http://schemas.microsoft.com/office/drawing/2018/hyperlinkcolor" val="tx"/>
+                    </a:ext>
+                  </a:extLst>
+                </a:hlinkClick>
+              </a:rPr>
+              <a:t>campodivittoria.github.io/GideonsTesoreria.app</a:t>
+            </a:r>
+            <a:endParaRPr lang="en-US" sz="900" dirty="0"/>
+          </a:p>
+        </p:txBody>
+      </p:sp>
+      <p:pic>
+        <p:nvPicPr>
+          <p:cNvPr id="30" name="Logo piccolo" descr="preencoded.png">
+            <a:hlinkClick r:id="rId9" tooltip="Apri l’app Tesoreria Campo Gedeoni"/>
+          </p:cNvPr>
+          <p:cNvPicPr>
+            <a:picLocks noChangeAspect="1"/>
+          </p:cNvPicPr>
+          <p:nvPr/>
+        </p:nvPicPr>
+        <p:blipFill>
+          <a:blip r:embed="rId8"/>
+          <a:stretch>
+            <a:fillRect/>
+          </a:stretch>
+        </p:blipFill>
+        <p:spPr>
+          <a:xfrm>
+            <a:off x="8366760" y="4572000"/>
+            <a:ext cx="365760" cy="365760"/>
+          </a:xfrm>
+          <a:prstGeom prst="rect">
+            <a:avLst/>
+          </a:prstGeom>
+        </p:spPr>
+      </p:pic>
     </p:spTree>
   </p:cSld>
   <p:clrMapOvr>

</xml_diff>

<commit_message>
Versione 4.1: indirizzo ufficiale gtesoreria.vercel.app nel pulsante Condividi e nelle slide
Co-Authored-By: Claude Opus 5.5 <noreply@anthropic.com>
Claude-Session: https://claude.ai/code/session_01Gg2EYwLr1DXy95Cqm3f4Zk
</commit_message>
<xml_diff>
--- a/presentazione/Tesoreria-Campo-Gedeoni.pptx
+++ b/presentazione/Tesoreria-Campo-Gedeoni.pptx
@@ -108,7 +108,7 @@
   <p:extLst>
     <p:ext uri="{521415D9-36F7-43E2-AB2F-B90AF26B5E84}">
       <p14:sectionLst xmlns:p14="http://schemas.microsoft.com/office/powerpoint/2010/main">
-        <p14:section name="Presentazione" id="{96e39be9-0415-43cf-2a63-cf85fed7f294}">
+        <p14:section name="Presentazione" id="{951a2ae6-ee52-031e-a48e-4166c3b21e6e}">
           <p14:sldIdLst>
             <p14:sldId id="256"/>
             <p14:sldId id="257"/>
@@ -1231,7 +1231,7 @@
                   </a:extLst>
                 </a:hlinkClick>
               </a:rPr>
-              <a:t>campodivittoria.github.io/GideonsTesoreria.app</a:t>
+              <a:t>gtesoreria.vercel.app</a:t>
             </a:r>
             <a:endParaRPr lang="en-US" sz="1400" dirty="0"/>
           </a:p>
@@ -1711,7 +1711,7 @@
                   <a:schemeClr val="accent5"/>
                 </a:solidFill>
               </a:rPr>
-              <a:t>Versione 3.7 · ottobre 2026</a:t>
+              <a:t>Versione 4.1 · ottobre 2026</a:t>
             </a:r>
             <a:endParaRPr lang="en-US" sz="1000" dirty="0"/>
           </a:p>
@@ -2617,7 +2617,7 @@
                   </a:extLst>
                 </a:hlinkClick>
               </a:rPr>
-              <a:t>campodivittoria.github.io/GideonsTesoreria.app</a:t>
+              <a:t>gtesoreria.vercel.app</a:t>
             </a:r>
             <a:endParaRPr lang="en-US" sz="900" dirty="0"/>
           </a:p>

</xml_diff>